<commit_message>
docs(pptx): slide indice avec top 10 communes + tuiles d'indicateurs infra frappants
- Slide 8 : carte + classement des 10 communes les plus vulnerables (indice colore).
- Slide 7 : 4 tuiles d'indicateurs frappants (0,66 toilette/ecole, 11 bibliotheques,
  29% sport, 17 ans d'age moyen).
</commit_message>
<xml_diff>
--- a/Presentation_Rapport_Analyse.pptx
+++ b/Presentation_Rapport_Analyse.pptx
@@ -6159,7 +6159,7 @@
                 </a:solidFill>
                 <a:latin typeface="Segoe UI"/>
               </a:rPr>
-              <a:t>Un déficit criant, concentré localement</a:t>
+              <a:t>Un déficit criant, en chiffres</a:t>
             </a:r>
           </a:p>
         </p:txBody>
@@ -6215,8 +6215,8 @@
         </p:blipFill>
         <p:spPr>
           <a:xfrm>
-            <a:off x="7952025" y="1371600"/>
-            <a:ext cx="3755550" cy="4480560"/>
+            <a:off x="7966820" y="1417320"/>
+            <a:ext cx="3908838" cy="4663440"/>
           </a:xfrm>
           <a:prstGeom prst="rect">
             <a:avLst/>
@@ -6225,14 +6225,282 @@
       </p:pic>
       <p:sp>
         <p:nvSpPr>
-          <p:cNvPr id="8" name="TextBox 7"/>
+          <p:cNvPr id="8" name="Rounded Rectangle 7"/>
+          <p:cNvSpPr/>
+          <p:nvPr/>
+        </p:nvSpPr>
+        <p:spPr>
+          <a:xfrm>
+            <a:off x="457200" y="1508760"/>
+            <a:ext cx="1737360" cy="1234440"/>
+          </a:xfrm>
+          <a:prstGeom prst="roundRect">
+            <a:avLst/>
+          </a:prstGeom>
+          <a:solidFill>
+            <a:srgbClr val="F2F6F4"/>
+          </a:solidFill>
+          <a:ln w="19050">
+            <a:solidFill>
+              <a:srgbClr val="EF3340"/>
+            </a:solidFill>
+          </a:ln>
+          <a:effectLst/>
+        </p:spPr>
+        <p:style>
+          <a:lnRef idx="1">
+            <a:schemeClr val="accent1"/>
+          </a:lnRef>
+          <a:fillRef idx="3">
+            <a:schemeClr val="accent1"/>
+          </a:fillRef>
+          <a:effectRef idx="2">
+            <a:schemeClr val="accent1"/>
+          </a:effectRef>
+          <a:fontRef idx="minor">
+            <a:schemeClr val="lt1"/>
+          </a:fontRef>
+        </p:style>
+        <p:txBody>
+          <a:bodyPr rtlCol="0" anchor="ctr" wrap="square" tIns="38100" bIns="38100"/>
+          <a:lstStyle/>
+          <a:p>
+            <a:pPr algn="ctr"/>
+            <a:r>
+              <a:rPr sz="2400" b="1">
+                <a:solidFill>
+                  <a:srgbClr val="EF3340"/>
+                </a:solidFill>
+                <a:latin typeface="Segoe UI"/>
+              </a:rPr>
+              <a:t>0,66</a:t>
+            </a:r>
+          </a:p>
+          <a:p>
+            <a:pPr algn="ctr"/>
+            <a:r>
+              <a:rPr sz="1050">
+                <a:solidFill>
+                  <a:srgbClr val="5B6B78"/>
+                </a:solidFill>
+                <a:latin typeface="Segoe UI"/>
+              </a:rPr>
+              <a:t>toilette / école</a:t>
+            </a:r>
+          </a:p>
+        </p:txBody>
+      </p:sp>
+      <p:sp>
+        <p:nvSpPr>
+          <p:cNvPr id="9" name="Rounded Rectangle 8"/>
+          <p:cNvSpPr/>
+          <p:nvPr/>
+        </p:nvSpPr>
+        <p:spPr>
+          <a:xfrm>
+            <a:off x="2286000" y="1508760"/>
+            <a:ext cx="1737360" cy="1234440"/>
+          </a:xfrm>
+          <a:prstGeom prst="roundRect">
+            <a:avLst/>
+          </a:prstGeom>
+          <a:solidFill>
+            <a:srgbClr val="F2F6F4"/>
+          </a:solidFill>
+          <a:ln w="19050">
+            <a:solidFill>
+              <a:srgbClr val="EF3340"/>
+            </a:solidFill>
+          </a:ln>
+          <a:effectLst/>
+        </p:spPr>
+        <p:style>
+          <a:lnRef idx="1">
+            <a:schemeClr val="accent1"/>
+          </a:lnRef>
+          <a:fillRef idx="3">
+            <a:schemeClr val="accent1"/>
+          </a:fillRef>
+          <a:effectRef idx="2">
+            <a:schemeClr val="accent1"/>
+          </a:effectRef>
+          <a:fontRef idx="minor">
+            <a:schemeClr val="lt1"/>
+          </a:fontRef>
+        </p:style>
+        <p:txBody>
+          <a:bodyPr rtlCol="0" anchor="ctr" wrap="square" tIns="38100" bIns="38100"/>
+          <a:lstStyle/>
+          <a:p>
+            <a:pPr algn="ctr"/>
+            <a:r>
+              <a:rPr sz="2400" b="1">
+                <a:solidFill>
+                  <a:srgbClr val="EF3340"/>
+                </a:solidFill>
+                <a:latin typeface="Segoe UI"/>
+              </a:rPr>
+              <a:t>11</a:t>
+            </a:r>
+          </a:p>
+          <a:p>
+            <a:pPr algn="ctr"/>
+            <a:r>
+              <a:rPr sz="1050">
+                <a:solidFill>
+                  <a:srgbClr val="5B6B78"/>
+                </a:solidFill>
+                <a:latin typeface="Segoe UI"/>
+              </a:rPr>
+              <a:t>bibliothèques (pays)</a:t>
+            </a:r>
+          </a:p>
+        </p:txBody>
+      </p:sp>
+      <p:sp>
+        <p:nvSpPr>
+          <p:cNvPr id="10" name="Rounded Rectangle 9"/>
+          <p:cNvSpPr/>
+          <p:nvPr/>
+        </p:nvSpPr>
+        <p:spPr>
+          <a:xfrm>
+            <a:off x="4114800" y="1508760"/>
+            <a:ext cx="1737360" cy="1234440"/>
+          </a:xfrm>
+          <a:prstGeom prst="roundRect">
+            <a:avLst/>
+          </a:prstGeom>
+          <a:solidFill>
+            <a:srgbClr val="F2F6F4"/>
+          </a:solidFill>
+          <a:ln w="19050">
+            <a:solidFill>
+              <a:srgbClr val="E1A100"/>
+            </a:solidFill>
+          </a:ln>
+          <a:effectLst/>
+        </p:spPr>
+        <p:style>
+          <a:lnRef idx="1">
+            <a:schemeClr val="accent1"/>
+          </a:lnRef>
+          <a:fillRef idx="3">
+            <a:schemeClr val="accent1"/>
+          </a:fillRef>
+          <a:effectRef idx="2">
+            <a:schemeClr val="accent1"/>
+          </a:effectRef>
+          <a:fontRef idx="minor">
+            <a:schemeClr val="lt1"/>
+          </a:fontRef>
+        </p:style>
+        <p:txBody>
+          <a:bodyPr rtlCol="0" anchor="ctr" wrap="square" tIns="38100" bIns="38100"/>
+          <a:lstStyle/>
+          <a:p>
+            <a:pPr algn="ctr"/>
+            <a:r>
+              <a:rPr sz="2400" b="1">
+                <a:solidFill>
+                  <a:srgbClr val="E1A100"/>
+                </a:solidFill>
+                <a:latin typeface="Segoe UI"/>
+              </a:rPr>
+              <a:t>29 %</a:t>
+            </a:r>
+          </a:p>
+          <a:p>
+            <a:pPr algn="ctr"/>
+            <a:r>
+              <a:rPr sz="1050">
+                <a:solidFill>
+                  <a:srgbClr val="5B6B78"/>
+                </a:solidFill>
+                <a:latin typeface="Segoe UI"/>
+              </a:rPr>
+              <a:t>écoles avec sport</a:t>
+            </a:r>
+          </a:p>
+        </p:txBody>
+      </p:sp>
+      <p:sp>
+        <p:nvSpPr>
+          <p:cNvPr id="11" name="Rounded Rectangle 10"/>
+          <p:cNvSpPr/>
+          <p:nvPr/>
+        </p:nvSpPr>
+        <p:spPr>
+          <a:xfrm>
+            <a:off x="5943600" y="1508760"/>
+            <a:ext cx="1737360" cy="1234440"/>
+          </a:xfrm>
+          <a:prstGeom prst="roundRect">
+            <a:avLst/>
+          </a:prstGeom>
+          <a:solidFill>
+            <a:srgbClr val="F2F6F4"/>
+          </a:solidFill>
+          <a:ln w="19050">
+            <a:solidFill>
+              <a:srgbClr val="E1A100"/>
+            </a:solidFill>
+          </a:ln>
+          <a:effectLst/>
+        </p:spPr>
+        <p:style>
+          <a:lnRef idx="1">
+            <a:schemeClr val="accent1"/>
+          </a:lnRef>
+          <a:fillRef idx="3">
+            <a:schemeClr val="accent1"/>
+          </a:fillRef>
+          <a:effectRef idx="2">
+            <a:schemeClr val="accent1"/>
+          </a:effectRef>
+          <a:fontRef idx="minor">
+            <a:schemeClr val="lt1"/>
+          </a:fontRef>
+        </p:style>
+        <p:txBody>
+          <a:bodyPr rtlCol="0" anchor="ctr" wrap="square" tIns="38100" bIns="38100"/>
+          <a:lstStyle/>
+          <a:p>
+            <a:pPr algn="ctr"/>
+            <a:r>
+              <a:rPr sz="2400" b="1">
+                <a:solidFill>
+                  <a:srgbClr val="E1A100"/>
+                </a:solidFill>
+                <a:latin typeface="Segoe UI"/>
+              </a:rPr>
+              <a:t>17 ans</a:t>
+            </a:r>
+          </a:p>
+          <a:p>
+            <a:pPr algn="ctr"/>
+            <a:r>
+              <a:rPr sz="1050">
+                <a:solidFill>
+                  <a:srgbClr val="5B6B78"/>
+                </a:solidFill>
+                <a:latin typeface="Segoe UI"/>
+              </a:rPr>
+              <a:t>âge moyen bâti</a:t>
+            </a:r>
+          </a:p>
+        </p:txBody>
+      </p:sp>
+      <p:sp>
+        <p:nvSpPr>
+          <p:cNvPr id="12" name="TextBox 11"/>
           <p:cNvSpPr txBox="1"/>
           <p:nvPr/>
         </p:nvSpPr>
         <p:spPr>
           <a:xfrm>
-            <a:off x="457200" y="1737360"/>
-            <a:ext cx="7040880" cy="4114800"/>
+            <a:off x="457200" y="3063240"/>
+            <a:ext cx="7223760" cy="3017520"/>
           </a:xfrm>
           <a:prstGeom prst="rect">
             <a:avLst/>
@@ -6247,86 +6515,59 @@
           <a:p>
             <a:pPr>
               <a:spcAft>
-                <a:spcPts val="1200"/>
+                <a:spcPts val="1100"/>
               </a:spcAft>
             </a:pPr>
             <a:r>
-              <a:rPr sz="1700">
+              <a:rPr sz="1500">
                 <a:solidFill>
                   <a:srgbClr val="1C2A33"/>
                 </a:solidFill>
                 <a:latin typeface="Segoe UI"/>
               </a:rPr>
-              <a:t>▸ Toilettes : </a:t>
-            </a:r>
-            <a:r>
-              <a:rPr sz="1700" b="1">
-                <a:solidFill>
-                  <a:srgbClr val="006A4E"/>
-                </a:solidFill>
-                <a:latin typeface="Segoe UI"/>
-              </a:rPr>
-              <a:t>0,66 bloc par école</a:t>
+              <a:t>▸ 33 des 39 préfectures n'ont AUCUNE bibliothèque.</a:t>
             </a:r>
           </a:p>
           <a:p>
             <a:pPr>
               <a:spcAft>
-                <a:spcPts val="1200"/>
+                <a:spcPts val="1100"/>
               </a:spcAft>
             </a:pPr>
             <a:r>
-              <a:rPr sz="1700">
+              <a:rPr sz="1500">
                 <a:solidFill>
                   <a:srgbClr val="1C2A33"/>
                 </a:solidFill>
                 <a:latin typeface="Segoe UI"/>
               </a:rPr>
-              <a:t>▸ Bibliothèques : </a:t>
-            </a:r>
-            <a:r>
-              <a:rPr sz="1700" b="1">
-                <a:solidFill>
-                  <a:srgbClr val="006A4E"/>
-                </a:solidFill>
-                <a:latin typeface="Segoe UI"/>
-              </a:rPr>
-              <a:t>11 dans tout le pays (33/39 préfectures sans)</a:t>
+              <a:t>▸ La densité de toilettes varie du simple au triple selon la commune.</a:t>
             </a:r>
           </a:p>
           <a:p>
             <a:pPr>
               <a:spcAft>
-                <a:spcPts val="1200"/>
+                <a:spcPts val="1100"/>
               </a:spcAft>
             </a:pPr>
             <a:r>
-              <a:rPr sz="1700">
+              <a:rPr sz="1500">
                 <a:solidFill>
                   <a:srgbClr val="1C2A33"/>
                 </a:solidFill>
                 <a:latin typeface="Segoe UI"/>
               </a:rPr>
-              <a:t>▸ Terrain de sport : </a:t>
-            </a:r>
-            <a:r>
-              <a:rPr sz="1700" b="1">
-                <a:solidFill>
-                  <a:srgbClr val="006A4E"/>
-                </a:solidFill>
-                <a:latin typeface="Segoe UI"/>
-              </a:rPr>
-              <a:t>29 % des écoles seulement</a:t>
+              <a:t>▸ Seulement 3 écoles sur 10 disposent d'un terrain de sport.</a:t>
             </a:r>
           </a:p>
           <a:p>
             <a:pPr>
               <a:spcAft>
-                <a:spcPts val="1200"/>
+                <a:spcPts val="1100"/>
               </a:spcAft>
             </a:pPr>
             <a:r>
-              <a:rPr sz="1700">
+              <a:rPr sz="1500">
                 <a:solidFill>
                   <a:srgbClr val="1C2A33"/>
                 </a:solidFill>
@@ -6508,7 +6749,7 @@
                 </a:solidFill>
                 <a:latin typeface="Segoe UI"/>
               </a:rPr>
-              <a:t>Mesurer le sous-équipement, jusqu'à la commune</a:t>
+              <a:t>Les 10 communes les plus prioritaires</a:t>
             </a:r>
           </a:p>
         </p:txBody>
@@ -6550,7 +6791,7 @@
       </p:sp>
       <p:pic>
         <p:nvPicPr>
-          <p:cNvPr id="7" name="Picture 6" descr="cercle.png"/>
+          <p:cNvPr id="7" name="Picture 6" descr="carte_pref.png"/>
           <p:cNvPicPr>
             <a:picLocks noChangeAspect="1"/>
           </p:cNvPicPr>
@@ -6564,38 +6805,58 @@
         </p:blipFill>
         <p:spPr>
           <a:xfrm>
-            <a:off x="457200" y="1691640"/>
-            <a:ext cx="3931919" cy="3931919"/>
+            <a:off x="477939" y="1188720"/>
+            <a:ext cx="3981882" cy="4937760"/>
           </a:xfrm>
           <a:prstGeom prst="rect">
             <a:avLst/>
           </a:prstGeom>
         </p:spPr>
       </p:pic>
-      <p:pic>
-        <p:nvPicPr>
-          <p:cNvPr id="8" name="Picture 7" descr="carte_pref.png"/>
-          <p:cNvPicPr>
-            <a:picLocks noChangeAspect="1"/>
-          </p:cNvPicPr>
-          <p:nvPr/>
-        </p:nvPicPr>
-        <p:blipFill>
-          <a:blip r:embed="rId3"/>
-          <a:stretch>
-            <a:fillRect/>
-          </a:stretch>
-        </p:blipFill>
-        <p:spPr>
-          <a:xfrm>
-            <a:off x="8229600" y="1378809"/>
-            <a:ext cx="3749039" cy="4649021"/>
-          </a:xfrm>
-          <a:prstGeom prst="rect">
-            <a:avLst/>
-          </a:prstGeom>
-        </p:spPr>
-      </p:pic>
+      <p:sp>
+        <p:nvSpPr>
+          <p:cNvPr id="8" name="Oval 7"/>
+          <p:cNvSpPr/>
+          <p:nvPr/>
+        </p:nvSpPr>
+        <p:spPr>
+          <a:xfrm>
+            <a:off x="4937760" y="1463040"/>
+            <a:ext cx="365760" cy="365760"/>
+          </a:xfrm>
+          <a:prstGeom prst="ellipse">
+            <a:avLst/>
+          </a:prstGeom>
+          <a:solidFill>
+            <a:srgbClr val="EF3340"/>
+          </a:solidFill>
+          <a:ln>
+            <a:noFill/>
+          </a:ln>
+          <a:effectLst/>
+        </p:spPr>
+        <p:style>
+          <a:lnRef idx="1">
+            <a:schemeClr val="accent1"/>
+          </a:lnRef>
+          <a:fillRef idx="3">
+            <a:schemeClr val="accent1"/>
+          </a:fillRef>
+          <a:effectRef idx="2">
+            <a:schemeClr val="accent1"/>
+          </a:effectRef>
+          <a:fontRef idx="minor">
+            <a:schemeClr val="lt1"/>
+          </a:fontRef>
+        </p:style>
+        <p:txBody>
+          <a:bodyPr rtlCol="0" anchor="ctr"/>
+          <a:lstStyle/>
+          <a:p>
+            <a:pPr algn="ctr"/>
+          </a:p>
+        </p:txBody>
+      </p:sp>
       <p:sp>
         <p:nvSpPr>
           <p:cNvPr id="9" name="TextBox 8"/>
@@ -6604,8 +6865,8 @@
         </p:nvSpPr>
         <p:spPr>
           <a:xfrm>
-            <a:off x="4480560" y="1737360"/>
-            <a:ext cx="3749039" cy="4206240"/>
+            <a:off x="4937760" y="1454040"/>
+            <a:ext cx="365760" cy="384048"/>
           </a:xfrm>
           <a:prstGeom prst="rect">
             <a:avLst/>
@@ -6613,81 +6874,1466 @@
           <a:noFill/>
         </p:spPr>
         <p:txBody>
-          <a:bodyPr wrap="square">
+          <a:bodyPr wrap="square" anchor="ctr">
             <a:spAutoFit/>
           </a:bodyPr>
           <a:lstStyle/>
           <a:p>
-            <a:pPr>
-              <a:spcAft>
-                <a:spcPts val="1000"/>
-              </a:spcAft>
-            </a:pPr>
-            <a:r>
-              <a:rPr sz="1400">
+            <a:pPr algn="ctr"/>
+            <a:r>
+              <a:rPr sz="1300" b="1">
+                <a:solidFill>
+                  <a:srgbClr val="FFFFFF"/>
+                </a:solidFill>
+                <a:latin typeface="Segoe UI"/>
+              </a:rPr>
+              <a:t>1</a:t>
+            </a:r>
+          </a:p>
+        </p:txBody>
+      </p:sp>
+      <p:sp>
+        <p:nvSpPr>
+          <p:cNvPr id="10" name="TextBox 9"/>
+          <p:cNvSpPr txBox="1"/>
+          <p:nvPr/>
+        </p:nvSpPr>
+        <p:spPr>
+          <a:xfrm>
+            <a:off x="5440680" y="1463040"/>
+            <a:ext cx="5394960" cy="384048"/>
+          </a:xfrm>
+          <a:prstGeom prst="rect">
+            <a:avLst/>
+          </a:prstGeom>
+          <a:noFill/>
+        </p:spPr>
+        <p:txBody>
+          <a:bodyPr wrap="square" anchor="ctr">
+            <a:spAutoFit/>
+          </a:bodyPr>
+          <a:lstStyle/>
+          <a:p>
+            <a:pPr algn="l"/>
+            <a:r>
+              <a:rPr sz="1400" b="0">
                 <a:solidFill>
                   <a:srgbClr val="1C2A33"/>
                 </a:solidFill>
                 <a:latin typeface="Segoe UI"/>
               </a:rPr>
-              <a:t>▸ Composite de 4 dimensions par école : toilettes, bâtiments, sport, ancienneté.</a:t>
-            </a:r>
-          </a:p>
-          <a:p>
-            <a:pPr>
-              <a:spcAft>
-                <a:spcPts val="1000"/>
-              </a:spcAft>
-            </a:pPr>
-            <a:r>
-              <a:rPr sz="1400">
+              <a:t>Golfe 1  (Golfe)</a:t>
+            </a:r>
+          </a:p>
+        </p:txBody>
+      </p:sp>
+      <p:sp>
+        <p:nvSpPr>
+          <p:cNvPr id="11" name="TextBox 10"/>
+          <p:cNvSpPr txBox="1"/>
+          <p:nvPr/>
+        </p:nvSpPr>
+        <p:spPr>
+          <a:xfrm>
+            <a:off x="10881360" y="1463040"/>
+            <a:ext cx="914400" cy="384048"/>
+          </a:xfrm>
+          <a:prstGeom prst="rect">
+            <a:avLst/>
+          </a:prstGeom>
+          <a:noFill/>
+        </p:spPr>
+        <p:txBody>
+          <a:bodyPr wrap="square" anchor="ctr">
+            <a:spAutoFit/>
+          </a:bodyPr>
+          <a:lstStyle/>
+          <a:p>
+            <a:pPr algn="r"/>
+            <a:r>
+              <a:rPr sz="1500" b="1">
+                <a:solidFill>
+                  <a:srgbClr val="EF3340"/>
+                </a:solidFill>
+                <a:latin typeface="Segoe UI"/>
+              </a:rPr>
+              <a:t>83</a:t>
+            </a:r>
+          </a:p>
+        </p:txBody>
+      </p:sp>
+      <p:sp>
+        <p:nvSpPr>
+          <p:cNvPr id="12" name="Oval 11"/>
+          <p:cNvSpPr/>
+          <p:nvPr/>
+        </p:nvSpPr>
+        <p:spPr>
+          <a:xfrm>
+            <a:off x="4937760" y="1874520"/>
+            <a:ext cx="365760" cy="365760"/>
+          </a:xfrm>
+          <a:prstGeom prst="ellipse">
+            <a:avLst/>
+          </a:prstGeom>
+          <a:solidFill>
+            <a:srgbClr val="EF3340"/>
+          </a:solidFill>
+          <a:ln>
+            <a:noFill/>
+          </a:ln>
+          <a:effectLst/>
+        </p:spPr>
+        <p:style>
+          <a:lnRef idx="1">
+            <a:schemeClr val="accent1"/>
+          </a:lnRef>
+          <a:fillRef idx="3">
+            <a:schemeClr val="accent1"/>
+          </a:fillRef>
+          <a:effectRef idx="2">
+            <a:schemeClr val="accent1"/>
+          </a:effectRef>
+          <a:fontRef idx="minor">
+            <a:schemeClr val="lt1"/>
+          </a:fontRef>
+        </p:style>
+        <p:txBody>
+          <a:bodyPr rtlCol="0" anchor="ctr"/>
+          <a:lstStyle/>
+          <a:p>
+            <a:pPr algn="ctr"/>
+          </a:p>
+        </p:txBody>
+      </p:sp>
+      <p:sp>
+        <p:nvSpPr>
+          <p:cNvPr id="13" name="TextBox 12"/>
+          <p:cNvSpPr txBox="1"/>
+          <p:nvPr/>
+        </p:nvSpPr>
+        <p:spPr>
+          <a:xfrm>
+            <a:off x="4937760" y="1865520"/>
+            <a:ext cx="365760" cy="384048"/>
+          </a:xfrm>
+          <a:prstGeom prst="rect">
+            <a:avLst/>
+          </a:prstGeom>
+          <a:noFill/>
+        </p:spPr>
+        <p:txBody>
+          <a:bodyPr wrap="square" anchor="ctr">
+            <a:spAutoFit/>
+          </a:bodyPr>
+          <a:lstStyle/>
+          <a:p>
+            <a:pPr algn="ctr"/>
+            <a:r>
+              <a:rPr sz="1300" b="1">
+                <a:solidFill>
+                  <a:srgbClr val="FFFFFF"/>
+                </a:solidFill>
+                <a:latin typeface="Segoe UI"/>
+              </a:rPr>
+              <a:t>2</a:t>
+            </a:r>
+          </a:p>
+        </p:txBody>
+      </p:sp>
+      <p:sp>
+        <p:nvSpPr>
+          <p:cNvPr id="14" name="TextBox 13"/>
+          <p:cNvSpPr txBox="1"/>
+          <p:nvPr/>
+        </p:nvSpPr>
+        <p:spPr>
+          <a:xfrm>
+            <a:off x="5440680" y="1874520"/>
+            <a:ext cx="5394960" cy="384048"/>
+          </a:xfrm>
+          <a:prstGeom prst="rect">
+            <a:avLst/>
+          </a:prstGeom>
+          <a:noFill/>
+        </p:spPr>
+        <p:txBody>
+          <a:bodyPr wrap="square" anchor="ctr">
+            <a:spAutoFit/>
+          </a:bodyPr>
+          <a:lstStyle/>
+          <a:p>
+            <a:pPr algn="l"/>
+            <a:r>
+              <a:rPr sz="1400" b="0">
                 <a:solidFill>
                   <a:srgbClr val="1C2A33"/>
                 </a:solidFill>
                 <a:latin typeface="Segoe UI"/>
               </a:rPr>
-              <a:t>▸ Normalisé 0–100, agrégé commune → préfecture → région.</a:t>
-            </a:r>
-          </a:p>
-          <a:p>
-            <a:pPr>
-              <a:spcAft>
-                <a:spcPts val="1000"/>
-              </a:spcAft>
-            </a:pPr>
-            <a:r>
-              <a:rPr sz="1400">
+              <a:t>Wawa 1  (Wawa)</a:t>
+            </a:r>
+          </a:p>
+        </p:txBody>
+      </p:sp>
+      <p:sp>
+        <p:nvSpPr>
+          <p:cNvPr id="15" name="TextBox 14"/>
+          <p:cNvSpPr txBox="1"/>
+          <p:nvPr/>
+        </p:nvSpPr>
+        <p:spPr>
+          <a:xfrm>
+            <a:off x="10881360" y="1874520"/>
+            <a:ext cx="914400" cy="384048"/>
+          </a:xfrm>
+          <a:prstGeom prst="rect">
+            <a:avLst/>
+          </a:prstGeom>
+          <a:noFill/>
+        </p:spPr>
+        <p:txBody>
+          <a:bodyPr wrap="square" anchor="ctr">
+            <a:spAutoFit/>
+          </a:bodyPr>
+          <a:lstStyle/>
+          <a:p>
+            <a:pPr algn="r"/>
+            <a:r>
+              <a:rPr sz="1500" b="1">
+                <a:solidFill>
+                  <a:srgbClr val="EF3340"/>
+                </a:solidFill>
+                <a:latin typeface="Segoe UI"/>
+              </a:rPr>
+              <a:t>82</a:t>
+            </a:r>
+          </a:p>
+        </p:txBody>
+      </p:sp>
+      <p:sp>
+        <p:nvSpPr>
+          <p:cNvPr id="16" name="Oval 15"/>
+          <p:cNvSpPr/>
+          <p:nvPr/>
+        </p:nvSpPr>
+        <p:spPr>
+          <a:xfrm>
+            <a:off x="4937760" y="2286000"/>
+            <a:ext cx="365760" cy="365760"/>
+          </a:xfrm>
+          <a:prstGeom prst="ellipse">
+            <a:avLst/>
+          </a:prstGeom>
+          <a:solidFill>
+            <a:srgbClr val="EF3340"/>
+          </a:solidFill>
+          <a:ln>
+            <a:noFill/>
+          </a:ln>
+          <a:effectLst/>
+        </p:spPr>
+        <p:style>
+          <a:lnRef idx="1">
+            <a:schemeClr val="accent1"/>
+          </a:lnRef>
+          <a:fillRef idx="3">
+            <a:schemeClr val="accent1"/>
+          </a:fillRef>
+          <a:effectRef idx="2">
+            <a:schemeClr val="accent1"/>
+          </a:effectRef>
+          <a:fontRef idx="minor">
+            <a:schemeClr val="lt1"/>
+          </a:fontRef>
+        </p:style>
+        <p:txBody>
+          <a:bodyPr rtlCol="0" anchor="ctr"/>
+          <a:lstStyle/>
+          <a:p>
+            <a:pPr algn="ctr"/>
+          </a:p>
+        </p:txBody>
+      </p:sp>
+      <p:sp>
+        <p:nvSpPr>
+          <p:cNvPr id="17" name="TextBox 16"/>
+          <p:cNvSpPr txBox="1"/>
+          <p:nvPr/>
+        </p:nvSpPr>
+        <p:spPr>
+          <a:xfrm>
+            <a:off x="4937760" y="2277000"/>
+            <a:ext cx="365760" cy="384048"/>
+          </a:xfrm>
+          <a:prstGeom prst="rect">
+            <a:avLst/>
+          </a:prstGeom>
+          <a:noFill/>
+        </p:spPr>
+        <p:txBody>
+          <a:bodyPr wrap="square" anchor="ctr">
+            <a:spAutoFit/>
+          </a:bodyPr>
+          <a:lstStyle/>
+          <a:p>
+            <a:pPr algn="ctr"/>
+            <a:r>
+              <a:rPr sz="1300" b="1">
+                <a:solidFill>
+                  <a:srgbClr val="FFFFFF"/>
+                </a:solidFill>
+                <a:latin typeface="Segoe UI"/>
+              </a:rPr>
+              <a:t>3</a:t>
+            </a:r>
+          </a:p>
+        </p:txBody>
+      </p:sp>
+      <p:sp>
+        <p:nvSpPr>
+          <p:cNvPr id="18" name="TextBox 17"/>
+          <p:cNvSpPr txBox="1"/>
+          <p:nvPr/>
+        </p:nvSpPr>
+        <p:spPr>
+          <a:xfrm>
+            <a:off x="5440680" y="2286000"/>
+            <a:ext cx="5394960" cy="384048"/>
+          </a:xfrm>
+          <a:prstGeom prst="rect">
+            <a:avLst/>
+          </a:prstGeom>
+          <a:noFill/>
+        </p:spPr>
+        <p:txBody>
+          <a:bodyPr wrap="square" anchor="ctr">
+            <a:spAutoFit/>
+          </a:bodyPr>
+          <a:lstStyle/>
+          <a:p>
+            <a:pPr algn="l"/>
+            <a:r>
+              <a:rPr sz="1400" b="0">
                 <a:solidFill>
                   <a:srgbClr val="1C2A33"/>
                 </a:solidFill>
                 <a:latin typeface="Segoe UI"/>
               </a:rPr>
-              <a:t>▸ Structure validée par ACP </a:t>
-            </a:r>
-            <a:r>
-              <a:rPr sz="1400" b="1">
-                <a:solidFill>
-                  <a:srgbClr val="006A4E"/>
-                </a:solidFill>
-                <a:latin typeface="Segoe UI"/>
-              </a:rPr>
-              <a:t>(64 % sur 2 axes)</a:t>
-            </a:r>
-          </a:p>
-          <a:p>
-            <a:pPr>
-              <a:spcAft>
-                <a:spcPts val="1000"/>
-              </a:spcAft>
-            </a:pPr>
-            <a:r>
-              <a:rPr sz="1400">
+              <a:t>Golfe 4  (Golfe)</a:t>
+            </a:r>
+          </a:p>
+        </p:txBody>
+      </p:sp>
+      <p:sp>
+        <p:nvSpPr>
+          <p:cNvPr id="19" name="TextBox 18"/>
+          <p:cNvSpPr txBox="1"/>
+          <p:nvPr/>
+        </p:nvSpPr>
+        <p:spPr>
+          <a:xfrm>
+            <a:off x="10881360" y="2286000"/>
+            <a:ext cx="914400" cy="384048"/>
+          </a:xfrm>
+          <a:prstGeom prst="rect">
+            <a:avLst/>
+          </a:prstGeom>
+          <a:noFill/>
+        </p:spPr>
+        <p:txBody>
+          <a:bodyPr wrap="square" anchor="ctr">
+            <a:spAutoFit/>
+          </a:bodyPr>
+          <a:lstStyle/>
+          <a:p>
+            <a:pPr algn="r"/>
+            <a:r>
+              <a:rPr sz="1500" b="1">
+                <a:solidFill>
+                  <a:srgbClr val="EF3340"/>
+                </a:solidFill>
+                <a:latin typeface="Segoe UI"/>
+              </a:rPr>
+              <a:t>78</a:t>
+            </a:r>
+          </a:p>
+        </p:txBody>
+      </p:sp>
+      <p:sp>
+        <p:nvSpPr>
+          <p:cNvPr id="20" name="Oval 19"/>
+          <p:cNvSpPr/>
+          <p:nvPr/>
+        </p:nvSpPr>
+        <p:spPr>
+          <a:xfrm>
+            <a:off x="4937760" y="2697480"/>
+            <a:ext cx="365760" cy="365760"/>
+          </a:xfrm>
+          <a:prstGeom prst="ellipse">
+            <a:avLst/>
+          </a:prstGeom>
+          <a:solidFill>
+            <a:srgbClr val="EF3340"/>
+          </a:solidFill>
+          <a:ln>
+            <a:noFill/>
+          </a:ln>
+          <a:effectLst/>
+        </p:spPr>
+        <p:style>
+          <a:lnRef idx="1">
+            <a:schemeClr val="accent1"/>
+          </a:lnRef>
+          <a:fillRef idx="3">
+            <a:schemeClr val="accent1"/>
+          </a:fillRef>
+          <a:effectRef idx="2">
+            <a:schemeClr val="accent1"/>
+          </a:effectRef>
+          <a:fontRef idx="minor">
+            <a:schemeClr val="lt1"/>
+          </a:fontRef>
+        </p:style>
+        <p:txBody>
+          <a:bodyPr rtlCol="0" anchor="ctr"/>
+          <a:lstStyle/>
+          <a:p>
+            <a:pPr algn="ctr"/>
+          </a:p>
+        </p:txBody>
+      </p:sp>
+      <p:sp>
+        <p:nvSpPr>
+          <p:cNvPr id="21" name="TextBox 20"/>
+          <p:cNvSpPr txBox="1"/>
+          <p:nvPr/>
+        </p:nvSpPr>
+        <p:spPr>
+          <a:xfrm>
+            <a:off x="4937760" y="2688480"/>
+            <a:ext cx="365760" cy="384048"/>
+          </a:xfrm>
+          <a:prstGeom prst="rect">
+            <a:avLst/>
+          </a:prstGeom>
+          <a:noFill/>
+        </p:spPr>
+        <p:txBody>
+          <a:bodyPr wrap="square" anchor="ctr">
+            <a:spAutoFit/>
+          </a:bodyPr>
+          <a:lstStyle/>
+          <a:p>
+            <a:pPr algn="ctr"/>
+            <a:r>
+              <a:rPr sz="1300" b="1">
+                <a:solidFill>
+                  <a:srgbClr val="FFFFFF"/>
+                </a:solidFill>
+                <a:latin typeface="Segoe UI"/>
+              </a:rPr>
+              <a:t>4</a:t>
+            </a:r>
+          </a:p>
+        </p:txBody>
+      </p:sp>
+      <p:sp>
+        <p:nvSpPr>
+          <p:cNvPr id="22" name="TextBox 21"/>
+          <p:cNvSpPr txBox="1"/>
+          <p:nvPr/>
+        </p:nvSpPr>
+        <p:spPr>
+          <a:xfrm>
+            <a:off x="5440680" y="2697480"/>
+            <a:ext cx="5394960" cy="384048"/>
+          </a:xfrm>
+          <a:prstGeom prst="rect">
+            <a:avLst/>
+          </a:prstGeom>
+          <a:noFill/>
+        </p:spPr>
+        <p:txBody>
+          <a:bodyPr wrap="square" anchor="ctr">
+            <a:spAutoFit/>
+          </a:bodyPr>
+          <a:lstStyle/>
+          <a:p>
+            <a:pPr algn="l"/>
+            <a:r>
+              <a:rPr sz="1400" b="0">
                 <a:solidFill>
                   <a:srgbClr val="1C2A33"/>
                 </a:solidFill>
                 <a:latin typeface="Segoe UI"/>
               </a:rPr>
-              <a:t>▸ Élevé = sous-équipé, prioritaire (rouge sur la carte).</a:t>
+              <a:t>Danyi 2  (Danyi)</a:t>
+            </a:r>
+          </a:p>
+        </p:txBody>
+      </p:sp>
+      <p:sp>
+        <p:nvSpPr>
+          <p:cNvPr id="23" name="TextBox 22"/>
+          <p:cNvSpPr txBox="1"/>
+          <p:nvPr/>
+        </p:nvSpPr>
+        <p:spPr>
+          <a:xfrm>
+            <a:off x="10881360" y="2697480"/>
+            <a:ext cx="914400" cy="384048"/>
+          </a:xfrm>
+          <a:prstGeom prst="rect">
+            <a:avLst/>
+          </a:prstGeom>
+          <a:noFill/>
+        </p:spPr>
+        <p:txBody>
+          <a:bodyPr wrap="square" anchor="ctr">
+            <a:spAutoFit/>
+          </a:bodyPr>
+          <a:lstStyle/>
+          <a:p>
+            <a:pPr algn="r"/>
+            <a:r>
+              <a:rPr sz="1500" b="1">
+                <a:solidFill>
+                  <a:srgbClr val="EF3340"/>
+                </a:solidFill>
+                <a:latin typeface="Segoe UI"/>
+              </a:rPr>
+              <a:t>78</a:t>
+            </a:r>
+          </a:p>
+        </p:txBody>
+      </p:sp>
+      <p:sp>
+        <p:nvSpPr>
+          <p:cNvPr id="24" name="Oval 23"/>
+          <p:cNvSpPr/>
+          <p:nvPr/>
+        </p:nvSpPr>
+        <p:spPr>
+          <a:xfrm>
+            <a:off x="4937760" y="3108960"/>
+            <a:ext cx="365760" cy="365760"/>
+          </a:xfrm>
+          <a:prstGeom prst="ellipse">
+            <a:avLst/>
+          </a:prstGeom>
+          <a:solidFill>
+            <a:srgbClr val="E1A100"/>
+          </a:solidFill>
+          <a:ln>
+            <a:noFill/>
+          </a:ln>
+          <a:effectLst/>
+        </p:spPr>
+        <p:style>
+          <a:lnRef idx="1">
+            <a:schemeClr val="accent1"/>
+          </a:lnRef>
+          <a:fillRef idx="3">
+            <a:schemeClr val="accent1"/>
+          </a:fillRef>
+          <a:effectRef idx="2">
+            <a:schemeClr val="accent1"/>
+          </a:effectRef>
+          <a:fontRef idx="minor">
+            <a:schemeClr val="lt1"/>
+          </a:fontRef>
+        </p:style>
+        <p:txBody>
+          <a:bodyPr rtlCol="0" anchor="ctr"/>
+          <a:lstStyle/>
+          <a:p>
+            <a:pPr algn="ctr"/>
+          </a:p>
+        </p:txBody>
+      </p:sp>
+      <p:sp>
+        <p:nvSpPr>
+          <p:cNvPr id="25" name="TextBox 24"/>
+          <p:cNvSpPr txBox="1"/>
+          <p:nvPr/>
+        </p:nvSpPr>
+        <p:spPr>
+          <a:xfrm>
+            <a:off x="4937760" y="3099960"/>
+            <a:ext cx="365760" cy="384048"/>
+          </a:xfrm>
+          <a:prstGeom prst="rect">
+            <a:avLst/>
+          </a:prstGeom>
+          <a:noFill/>
+        </p:spPr>
+        <p:txBody>
+          <a:bodyPr wrap="square" anchor="ctr">
+            <a:spAutoFit/>
+          </a:bodyPr>
+          <a:lstStyle/>
+          <a:p>
+            <a:pPr algn="ctr"/>
+            <a:r>
+              <a:rPr sz="1300" b="1">
+                <a:solidFill>
+                  <a:srgbClr val="FFFFFF"/>
+                </a:solidFill>
+                <a:latin typeface="Segoe UI"/>
+              </a:rPr>
+              <a:t>5</a:t>
+            </a:r>
+          </a:p>
+        </p:txBody>
+      </p:sp>
+      <p:sp>
+        <p:nvSpPr>
+          <p:cNvPr id="26" name="TextBox 25"/>
+          <p:cNvSpPr txBox="1"/>
+          <p:nvPr/>
+        </p:nvSpPr>
+        <p:spPr>
+          <a:xfrm>
+            <a:off x="5440680" y="3108960"/>
+            <a:ext cx="5394960" cy="384048"/>
+          </a:xfrm>
+          <a:prstGeom prst="rect">
+            <a:avLst/>
+          </a:prstGeom>
+          <a:noFill/>
+        </p:spPr>
+        <p:txBody>
+          <a:bodyPr wrap="square" anchor="ctr">
+            <a:spAutoFit/>
+          </a:bodyPr>
+          <a:lstStyle/>
+          <a:p>
+            <a:pPr algn="l"/>
+            <a:r>
+              <a:rPr sz="1400" b="0">
+                <a:solidFill>
+                  <a:srgbClr val="1C2A33"/>
+                </a:solidFill>
+                <a:latin typeface="Segoe UI"/>
+              </a:rPr>
+              <a:t>Kloto 1  (Kloto)</a:t>
+            </a:r>
+          </a:p>
+        </p:txBody>
+      </p:sp>
+      <p:sp>
+        <p:nvSpPr>
+          <p:cNvPr id="27" name="TextBox 26"/>
+          <p:cNvSpPr txBox="1"/>
+          <p:nvPr/>
+        </p:nvSpPr>
+        <p:spPr>
+          <a:xfrm>
+            <a:off x="10881360" y="3108960"/>
+            <a:ext cx="914400" cy="384048"/>
+          </a:xfrm>
+          <a:prstGeom prst="rect">
+            <a:avLst/>
+          </a:prstGeom>
+          <a:noFill/>
+        </p:spPr>
+        <p:txBody>
+          <a:bodyPr wrap="square" anchor="ctr">
+            <a:spAutoFit/>
+          </a:bodyPr>
+          <a:lstStyle/>
+          <a:p>
+            <a:pPr algn="r"/>
+            <a:r>
+              <a:rPr sz="1500" b="1">
+                <a:solidFill>
+                  <a:srgbClr val="E1A100"/>
+                </a:solidFill>
+                <a:latin typeface="Segoe UI"/>
+              </a:rPr>
+              <a:t>78</a:t>
+            </a:r>
+          </a:p>
+        </p:txBody>
+      </p:sp>
+      <p:sp>
+        <p:nvSpPr>
+          <p:cNvPr id="28" name="Oval 27"/>
+          <p:cNvSpPr/>
+          <p:nvPr/>
+        </p:nvSpPr>
+        <p:spPr>
+          <a:xfrm>
+            <a:off x="4937760" y="3520440"/>
+            <a:ext cx="365760" cy="365760"/>
+          </a:xfrm>
+          <a:prstGeom prst="ellipse">
+            <a:avLst/>
+          </a:prstGeom>
+          <a:solidFill>
+            <a:srgbClr val="E1A100"/>
+          </a:solidFill>
+          <a:ln>
+            <a:noFill/>
+          </a:ln>
+          <a:effectLst/>
+        </p:spPr>
+        <p:style>
+          <a:lnRef idx="1">
+            <a:schemeClr val="accent1"/>
+          </a:lnRef>
+          <a:fillRef idx="3">
+            <a:schemeClr val="accent1"/>
+          </a:fillRef>
+          <a:effectRef idx="2">
+            <a:schemeClr val="accent1"/>
+          </a:effectRef>
+          <a:fontRef idx="minor">
+            <a:schemeClr val="lt1"/>
+          </a:fontRef>
+        </p:style>
+        <p:txBody>
+          <a:bodyPr rtlCol="0" anchor="ctr"/>
+          <a:lstStyle/>
+          <a:p>
+            <a:pPr algn="ctr"/>
+          </a:p>
+        </p:txBody>
+      </p:sp>
+      <p:sp>
+        <p:nvSpPr>
+          <p:cNvPr id="29" name="TextBox 28"/>
+          <p:cNvSpPr txBox="1"/>
+          <p:nvPr/>
+        </p:nvSpPr>
+        <p:spPr>
+          <a:xfrm>
+            <a:off x="4937760" y="3511440"/>
+            <a:ext cx="365760" cy="384048"/>
+          </a:xfrm>
+          <a:prstGeom prst="rect">
+            <a:avLst/>
+          </a:prstGeom>
+          <a:noFill/>
+        </p:spPr>
+        <p:txBody>
+          <a:bodyPr wrap="square" anchor="ctr">
+            <a:spAutoFit/>
+          </a:bodyPr>
+          <a:lstStyle/>
+          <a:p>
+            <a:pPr algn="ctr"/>
+            <a:r>
+              <a:rPr sz="1300" b="1">
+                <a:solidFill>
+                  <a:srgbClr val="FFFFFF"/>
+                </a:solidFill>
+                <a:latin typeface="Segoe UI"/>
+              </a:rPr>
+              <a:t>6</a:t>
+            </a:r>
+          </a:p>
+        </p:txBody>
+      </p:sp>
+      <p:sp>
+        <p:nvSpPr>
+          <p:cNvPr id="30" name="TextBox 29"/>
+          <p:cNvSpPr txBox="1"/>
+          <p:nvPr/>
+        </p:nvSpPr>
+        <p:spPr>
+          <a:xfrm>
+            <a:off x="5440680" y="3520440"/>
+            <a:ext cx="5394960" cy="384048"/>
+          </a:xfrm>
+          <a:prstGeom prst="rect">
+            <a:avLst/>
+          </a:prstGeom>
+          <a:noFill/>
+        </p:spPr>
+        <p:txBody>
+          <a:bodyPr wrap="square" anchor="ctr">
+            <a:spAutoFit/>
+          </a:bodyPr>
+          <a:lstStyle/>
+          <a:p>
+            <a:pPr algn="l"/>
+            <a:r>
+              <a:rPr sz="1400" b="0">
+                <a:solidFill>
+                  <a:srgbClr val="1C2A33"/>
+                </a:solidFill>
+                <a:latin typeface="Segoe UI"/>
+              </a:rPr>
+              <a:t>Golfe 2  (Golfe)</a:t>
+            </a:r>
+          </a:p>
+        </p:txBody>
+      </p:sp>
+      <p:sp>
+        <p:nvSpPr>
+          <p:cNvPr id="31" name="TextBox 30"/>
+          <p:cNvSpPr txBox="1"/>
+          <p:nvPr/>
+        </p:nvSpPr>
+        <p:spPr>
+          <a:xfrm>
+            <a:off x="10881360" y="3520440"/>
+            <a:ext cx="914400" cy="384048"/>
+          </a:xfrm>
+          <a:prstGeom prst="rect">
+            <a:avLst/>
+          </a:prstGeom>
+          <a:noFill/>
+        </p:spPr>
+        <p:txBody>
+          <a:bodyPr wrap="square" anchor="ctr">
+            <a:spAutoFit/>
+          </a:bodyPr>
+          <a:lstStyle/>
+          <a:p>
+            <a:pPr algn="r"/>
+            <a:r>
+              <a:rPr sz="1500" b="1">
+                <a:solidFill>
+                  <a:srgbClr val="E1A100"/>
+                </a:solidFill>
+                <a:latin typeface="Segoe UI"/>
+              </a:rPr>
+              <a:t>73</a:t>
+            </a:r>
+          </a:p>
+        </p:txBody>
+      </p:sp>
+      <p:sp>
+        <p:nvSpPr>
+          <p:cNvPr id="32" name="Oval 31"/>
+          <p:cNvSpPr/>
+          <p:nvPr/>
+        </p:nvSpPr>
+        <p:spPr>
+          <a:xfrm>
+            <a:off x="4937760" y="3931920"/>
+            <a:ext cx="365760" cy="365760"/>
+          </a:xfrm>
+          <a:prstGeom prst="ellipse">
+            <a:avLst/>
+          </a:prstGeom>
+          <a:solidFill>
+            <a:srgbClr val="E1A100"/>
+          </a:solidFill>
+          <a:ln>
+            <a:noFill/>
+          </a:ln>
+          <a:effectLst/>
+        </p:spPr>
+        <p:style>
+          <a:lnRef idx="1">
+            <a:schemeClr val="accent1"/>
+          </a:lnRef>
+          <a:fillRef idx="3">
+            <a:schemeClr val="accent1"/>
+          </a:fillRef>
+          <a:effectRef idx="2">
+            <a:schemeClr val="accent1"/>
+          </a:effectRef>
+          <a:fontRef idx="minor">
+            <a:schemeClr val="lt1"/>
+          </a:fontRef>
+        </p:style>
+        <p:txBody>
+          <a:bodyPr rtlCol="0" anchor="ctr"/>
+          <a:lstStyle/>
+          <a:p>
+            <a:pPr algn="ctr"/>
+          </a:p>
+        </p:txBody>
+      </p:sp>
+      <p:sp>
+        <p:nvSpPr>
+          <p:cNvPr id="33" name="TextBox 32"/>
+          <p:cNvSpPr txBox="1"/>
+          <p:nvPr/>
+        </p:nvSpPr>
+        <p:spPr>
+          <a:xfrm>
+            <a:off x="4937760" y="3922920"/>
+            <a:ext cx="365760" cy="384048"/>
+          </a:xfrm>
+          <a:prstGeom prst="rect">
+            <a:avLst/>
+          </a:prstGeom>
+          <a:noFill/>
+        </p:spPr>
+        <p:txBody>
+          <a:bodyPr wrap="square" anchor="ctr">
+            <a:spAutoFit/>
+          </a:bodyPr>
+          <a:lstStyle/>
+          <a:p>
+            <a:pPr algn="ctr"/>
+            <a:r>
+              <a:rPr sz="1300" b="1">
+                <a:solidFill>
+                  <a:srgbClr val="FFFFFF"/>
+                </a:solidFill>
+                <a:latin typeface="Segoe UI"/>
+              </a:rPr>
+              <a:t>7</a:t>
+            </a:r>
+          </a:p>
+        </p:txBody>
+      </p:sp>
+      <p:sp>
+        <p:nvSpPr>
+          <p:cNvPr id="34" name="TextBox 33"/>
+          <p:cNvSpPr txBox="1"/>
+          <p:nvPr/>
+        </p:nvSpPr>
+        <p:spPr>
+          <a:xfrm>
+            <a:off x="5440680" y="3931920"/>
+            <a:ext cx="5394960" cy="384048"/>
+          </a:xfrm>
+          <a:prstGeom prst="rect">
+            <a:avLst/>
+          </a:prstGeom>
+          <a:noFill/>
+        </p:spPr>
+        <p:txBody>
+          <a:bodyPr wrap="square" anchor="ctr">
+            <a:spAutoFit/>
+          </a:bodyPr>
+          <a:lstStyle/>
+          <a:p>
+            <a:pPr algn="l"/>
+            <a:r>
+              <a:rPr sz="1400" b="0">
+                <a:solidFill>
+                  <a:srgbClr val="1C2A33"/>
+                </a:solidFill>
+                <a:latin typeface="Segoe UI"/>
+              </a:rPr>
+              <a:t>Danyi 1  (Danyi)</a:t>
+            </a:r>
+          </a:p>
+        </p:txBody>
+      </p:sp>
+      <p:sp>
+        <p:nvSpPr>
+          <p:cNvPr id="35" name="TextBox 34"/>
+          <p:cNvSpPr txBox="1"/>
+          <p:nvPr/>
+        </p:nvSpPr>
+        <p:spPr>
+          <a:xfrm>
+            <a:off x="10881360" y="3931920"/>
+            <a:ext cx="914400" cy="384048"/>
+          </a:xfrm>
+          <a:prstGeom prst="rect">
+            <a:avLst/>
+          </a:prstGeom>
+          <a:noFill/>
+        </p:spPr>
+        <p:txBody>
+          <a:bodyPr wrap="square" anchor="ctr">
+            <a:spAutoFit/>
+          </a:bodyPr>
+          <a:lstStyle/>
+          <a:p>
+            <a:pPr algn="r"/>
+            <a:r>
+              <a:rPr sz="1500" b="1">
+                <a:solidFill>
+                  <a:srgbClr val="E1A100"/>
+                </a:solidFill>
+                <a:latin typeface="Segoe UI"/>
+              </a:rPr>
+              <a:t>73</a:t>
+            </a:r>
+          </a:p>
+        </p:txBody>
+      </p:sp>
+      <p:sp>
+        <p:nvSpPr>
+          <p:cNvPr id="36" name="Oval 35"/>
+          <p:cNvSpPr/>
+          <p:nvPr/>
+        </p:nvSpPr>
+        <p:spPr>
+          <a:xfrm>
+            <a:off x="4937760" y="4343400"/>
+            <a:ext cx="365760" cy="365760"/>
+          </a:xfrm>
+          <a:prstGeom prst="ellipse">
+            <a:avLst/>
+          </a:prstGeom>
+          <a:solidFill>
+            <a:srgbClr val="E1A100"/>
+          </a:solidFill>
+          <a:ln>
+            <a:noFill/>
+          </a:ln>
+          <a:effectLst/>
+        </p:spPr>
+        <p:style>
+          <a:lnRef idx="1">
+            <a:schemeClr val="accent1"/>
+          </a:lnRef>
+          <a:fillRef idx="3">
+            <a:schemeClr val="accent1"/>
+          </a:fillRef>
+          <a:effectRef idx="2">
+            <a:schemeClr val="accent1"/>
+          </a:effectRef>
+          <a:fontRef idx="minor">
+            <a:schemeClr val="lt1"/>
+          </a:fontRef>
+        </p:style>
+        <p:txBody>
+          <a:bodyPr rtlCol="0" anchor="ctr"/>
+          <a:lstStyle/>
+          <a:p>
+            <a:pPr algn="ctr"/>
+          </a:p>
+        </p:txBody>
+      </p:sp>
+      <p:sp>
+        <p:nvSpPr>
+          <p:cNvPr id="37" name="TextBox 36"/>
+          <p:cNvSpPr txBox="1"/>
+          <p:nvPr/>
+        </p:nvSpPr>
+        <p:spPr>
+          <a:xfrm>
+            <a:off x="4937760" y="4334400"/>
+            <a:ext cx="365760" cy="384048"/>
+          </a:xfrm>
+          <a:prstGeom prst="rect">
+            <a:avLst/>
+          </a:prstGeom>
+          <a:noFill/>
+        </p:spPr>
+        <p:txBody>
+          <a:bodyPr wrap="square" anchor="ctr">
+            <a:spAutoFit/>
+          </a:bodyPr>
+          <a:lstStyle/>
+          <a:p>
+            <a:pPr algn="ctr"/>
+            <a:r>
+              <a:rPr sz="1300" b="1">
+                <a:solidFill>
+                  <a:srgbClr val="FFFFFF"/>
+                </a:solidFill>
+                <a:latin typeface="Segoe UI"/>
+              </a:rPr>
+              <a:t>8</a:t>
+            </a:r>
+          </a:p>
+        </p:txBody>
+      </p:sp>
+      <p:sp>
+        <p:nvSpPr>
+          <p:cNvPr id="38" name="TextBox 37"/>
+          <p:cNvSpPr txBox="1"/>
+          <p:nvPr/>
+        </p:nvSpPr>
+        <p:spPr>
+          <a:xfrm>
+            <a:off x="5440680" y="4343400"/>
+            <a:ext cx="5394960" cy="384048"/>
+          </a:xfrm>
+          <a:prstGeom prst="rect">
+            <a:avLst/>
+          </a:prstGeom>
+          <a:noFill/>
+        </p:spPr>
+        <p:txBody>
+          <a:bodyPr wrap="square" anchor="ctr">
+            <a:spAutoFit/>
+          </a:bodyPr>
+          <a:lstStyle/>
+          <a:p>
+            <a:pPr algn="l"/>
+            <a:r>
+              <a:rPr sz="1400" b="0">
+                <a:solidFill>
+                  <a:srgbClr val="1C2A33"/>
+                </a:solidFill>
+                <a:latin typeface="Segoe UI"/>
+              </a:rPr>
+              <a:t>Agoè-Nyivé 1  (Agoè-Nyivé)</a:t>
+            </a:r>
+          </a:p>
+        </p:txBody>
+      </p:sp>
+      <p:sp>
+        <p:nvSpPr>
+          <p:cNvPr id="39" name="TextBox 38"/>
+          <p:cNvSpPr txBox="1"/>
+          <p:nvPr/>
+        </p:nvSpPr>
+        <p:spPr>
+          <a:xfrm>
+            <a:off x="10881360" y="4343400"/>
+            <a:ext cx="914400" cy="384048"/>
+          </a:xfrm>
+          <a:prstGeom prst="rect">
+            <a:avLst/>
+          </a:prstGeom>
+          <a:noFill/>
+        </p:spPr>
+        <p:txBody>
+          <a:bodyPr wrap="square" anchor="ctr">
+            <a:spAutoFit/>
+          </a:bodyPr>
+          <a:lstStyle/>
+          <a:p>
+            <a:pPr algn="r"/>
+            <a:r>
+              <a:rPr sz="1500" b="1">
+                <a:solidFill>
+                  <a:srgbClr val="E1A100"/>
+                </a:solidFill>
+                <a:latin typeface="Segoe UI"/>
+              </a:rPr>
+              <a:t>72</a:t>
+            </a:r>
+          </a:p>
+        </p:txBody>
+      </p:sp>
+      <p:sp>
+        <p:nvSpPr>
+          <p:cNvPr id="40" name="Oval 39"/>
+          <p:cNvSpPr/>
+          <p:nvPr/>
+        </p:nvSpPr>
+        <p:spPr>
+          <a:xfrm>
+            <a:off x="4937760" y="4754880"/>
+            <a:ext cx="365760" cy="365760"/>
+          </a:xfrm>
+          <a:prstGeom prst="ellipse">
+            <a:avLst/>
+          </a:prstGeom>
+          <a:solidFill>
+            <a:srgbClr val="E1A100"/>
+          </a:solidFill>
+          <a:ln>
+            <a:noFill/>
+          </a:ln>
+          <a:effectLst/>
+        </p:spPr>
+        <p:style>
+          <a:lnRef idx="1">
+            <a:schemeClr val="accent1"/>
+          </a:lnRef>
+          <a:fillRef idx="3">
+            <a:schemeClr val="accent1"/>
+          </a:fillRef>
+          <a:effectRef idx="2">
+            <a:schemeClr val="accent1"/>
+          </a:effectRef>
+          <a:fontRef idx="minor">
+            <a:schemeClr val="lt1"/>
+          </a:fontRef>
+        </p:style>
+        <p:txBody>
+          <a:bodyPr rtlCol="0" anchor="ctr"/>
+          <a:lstStyle/>
+          <a:p>
+            <a:pPr algn="ctr"/>
+          </a:p>
+        </p:txBody>
+      </p:sp>
+      <p:sp>
+        <p:nvSpPr>
+          <p:cNvPr id="41" name="TextBox 40"/>
+          <p:cNvSpPr txBox="1"/>
+          <p:nvPr/>
+        </p:nvSpPr>
+        <p:spPr>
+          <a:xfrm>
+            <a:off x="4937760" y="4745880"/>
+            <a:ext cx="365760" cy="384048"/>
+          </a:xfrm>
+          <a:prstGeom prst="rect">
+            <a:avLst/>
+          </a:prstGeom>
+          <a:noFill/>
+        </p:spPr>
+        <p:txBody>
+          <a:bodyPr wrap="square" anchor="ctr">
+            <a:spAutoFit/>
+          </a:bodyPr>
+          <a:lstStyle/>
+          <a:p>
+            <a:pPr algn="ctr"/>
+            <a:r>
+              <a:rPr sz="1300" b="1">
+                <a:solidFill>
+                  <a:srgbClr val="FFFFFF"/>
+                </a:solidFill>
+                <a:latin typeface="Segoe UI"/>
+              </a:rPr>
+              <a:t>9</a:t>
+            </a:r>
+          </a:p>
+        </p:txBody>
+      </p:sp>
+      <p:sp>
+        <p:nvSpPr>
+          <p:cNvPr id="42" name="TextBox 41"/>
+          <p:cNvSpPr txBox="1"/>
+          <p:nvPr/>
+        </p:nvSpPr>
+        <p:spPr>
+          <a:xfrm>
+            <a:off x="5440680" y="4754880"/>
+            <a:ext cx="5394960" cy="384048"/>
+          </a:xfrm>
+          <a:prstGeom prst="rect">
+            <a:avLst/>
+          </a:prstGeom>
+          <a:noFill/>
+        </p:spPr>
+        <p:txBody>
+          <a:bodyPr wrap="square" anchor="ctr">
+            <a:spAutoFit/>
+          </a:bodyPr>
+          <a:lstStyle/>
+          <a:p>
+            <a:pPr algn="l"/>
+            <a:r>
+              <a:rPr sz="1400" b="0">
+                <a:solidFill>
+                  <a:srgbClr val="1C2A33"/>
+                </a:solidFill>
+                <a:latin typeface="Segoe UI"/>
+              </a:rPr>
+              <a:t>Lacs 3  (Lacs)</a:t>
+            </a:r>
+          </a:p>
+        </p:txBody>
+      </p:sp>
+      <p:sp>
+        <p:nvSpPr>
+          <p:cNvPr id="43" name="TextBox 42"/>
+          <p:cNvSpPr txBox="1"/>
+          <p:nvPr/>
+        </p:nvSpPr>
+        <p:spPr>
+          <a:xfrm>
+            <a:off x="10881360" y="4754880"/>
+            <a:ext cx="914400" cy="384048"/>
+          </a:xfrm>
+          <a:prstGeom prst="rect">
+            <a:avLst/>
+          </a:prstGeom>
+          <a:noFill/>
+        </p:spPr>
+        <p:txBody>
+          <a:bodyPr wrap="square" anchor="ctr">
+            <a:spAutoFit/>
+          </a:bodyPr>
+          <a:lstStyle/>
+          <a:p>
+            <a:pPr algn="r"/>
+            <a:r>
+              <a:rPr sz="1500" b="1">
+                <a:solidFill>
+                  <a:srgbClr val="E1A100"/>
+                </a:solidFill>
+                <a:latin typeface="Segoe UI"/>
+              </a:rPr>
+              <a:t>71</a:t>
+            </a:r>
+          </a:p>
+        </p:txBody>
+      </p:sp>
+      <p:sp>
+        <p:nvSpPr>
+          <p:cNvPr id="44" name="Oval 43"/>
+          <p:cNvSpPr/>
+          <p:nvPr/>
+        </p:nvSpPr>
+        <p:spPr>
+          <a:xfrm>
+            <a:off x="4937760" y="5166360"/>
+            <a:ext cx="365760" cy="365760"/>
+          </a:xfrm>
+          <a:prstGeom prst="ellipse">
+            <a:avLst/>
+          </a:prstGeom>
+          <a:solidFill>
+            <a:srgbClr val="E1A100"/>
+          </a:solidFill>
+          <a:ln>
+            <a:noFill/>
+          </a:ln>
+          <a:effectLst/>
+        </p:spPr>
+        <p:style>
+          <a:lnRef idx="1">
+            <a:schemeClr val="accent1"/>
+          </a:lnRef>
+          <a:fillRef idx="3">
+            <a:schemeClr val="accent1"/>
+          </a:fillRef>
+          <a:effectRef idx="2">
+            <a:schemeClr val="accent1"/>
+          </a:effectRef>
+          <a:fontRef idx="minor">
+            <a:schemeClr val="lt1"/>
+          </a:fontRef>
+        </p:style>
+        <p:txBody>
+          <a:bodyPr rtlCol="0" anchor="ctr"/>
+          <a:lstStyle/>
+          <a:p>
+            <a:pPr algn="ctr"/>
+          </a:p>
+        </p:txBody>
+      </p:sp>
+      <p:sp>
+        <p:nvSpPr>
+          <p:cNvPr id="45" name="TextBox 44"/>
+          <p:cNvSpPr txBox="1"/>
+          <p:nvPr/>
+        </p:nvSpPr>
+        <p:spPr>
+          <a:xfrm>
+            <a:off x="4937760" y="5157360"/>
+            <a:ext cx="365760" cy="384048"/>
+          </a:xfrm>
+          <a:prstGeom prst="rect">
+            <a:avLst/>
+          </a:prstGeom>
+          <a:noFill/>
+        </p:spPr>
+        <p:txBody>
+          <a:bodyPr wrap="square" anchor="ctr">
+            <a:spAutoFit/>
+          </a:bodyPr>
+          <a:lstStyle/>
+          <a:p>
+            <a:pPr algn="ctr"/>
+            <a:r>
+              <a:rPr sz="1300" b="1">
+                <a:solidFill>
+                  <a:srgbClr val="FFFFFF"/>
+                </a:solidFill>
+                <a:latin typeface="Segoe UI"/>
+              </a:rPr>
+              <a:t>10</a:t>
+            </a:r>
+          </a:p>
+        </p:txBody>
+      </p:sp>
+      <p:sp>
+        <p:nvSpPr>
+          <p:cNvPr id="46" name="TextBox 45"/>
+          <p:cNvSpPr txBox="1"/>
+          <p:nvPr/>
+        </p:nvSpPr>
+        <p:spPr>
+          <a:xfrm>
+            <a:off x="5440680" y="5166360"/>
+            <a:ext cx="5394960" cy="384048"/>
+          </a:xfrm>
+          <a:prstGeom prst="rect">
+            <a:avLst/>
+          </a:prstGeom>
+          <a:noFill/>
+        </p:spPr>
+        <p:txBody>
+          <a:bodyPr wrap="square" anchor="ctr">
+            <a:spAutoFit/>
+          </a:bodyPr>
+          <a:lstStyle/>
+          <a:p>
+            <a:pPr algn="l"/>
+            <a:r>
+              <a:rPr sz="1400" b="0">
+                <a:solidFill>
+                  <a:srgbClr val="1C2A33"/>
+                </a:solidFill>
+                <a:latin typeface="Segoe UI"/>
+              </a:rPr>
+              <a:t>Agou 1  (Agou)</a:t>
+            </a:r>
+          </a:p>
+        </p:txBody>
+      </p:sp>
+      <p:sp>
+        <p:nvSpPr>
+          <p:cNvPr id="47" name="TextBox 46"/>
+          <p:cNvSpPr txBox="1"/>
+          <p:nvPr/>
+        </p:nvSpPr>
+        <p:spPr>
+          <a:xfrm>
+            <a:off x="10881360" y="5166360"/>
+            <a:ext cx="914400" cy="384048"/>
+          </a:xfrm>
+          <a:prstGeom prst="rect">
+            <a:avLst/>
+          </a:prstGeom>
+          <a:noFill/>
+        </p:spPr>
+        <p:txBody>
+          <a:bodyPr wrap="square" anchor="ctr">
+            <a:spAutoFit/>
+          </a:bodyPr>
+          <a:lstStyle/>
+          <a:p>
+            <a:pPr algn="r"/>
+            <a:r>
+              <a:rPr sz="1500" b="1">
+                <a:solidFill>
+                  <a:srgbClr val="E1A100"/>
+                </a:solidFill>
+                <a:latin typeface="Segoe UI"/>
+              </a:rPr>
+              <a:t>71</a:t>
+            </a:r>
+          </a:p>
+        </p:txBody>
+      </p:sp>
+      <p:sp>
+        <p:nvSpPr>
+          <p:cNvPr id="48" name="TextBox 47"/>
+          <p:cNvSpPr txBox="1"/>
+          <p:nvPr/>
+        </p:nvSpPr>
+        <p:spPr>
+          <a:xfrm>
+            <a:off x="4937760" y="5806440"/>
+            <a:ext cx="6949440" cy="457200"/>
+          </a:xfrm>
+          <a:prstGeom prst="rect">
+            <a:avLst/>
+          </a:prstGeom>
+          <a:noFill/>
+        </p:spPr>
+        <p:txBody>
+          <a:bodyPr wrap="square" anchor="t">
+            <a:spAutoFit/>
+          </a:bodyPr>
+          <a:lstStyle/>
+          <a:p>
+            <a:pPr algn="l"/>
+            <a:r>
+              <a:rPr sz="1100" b="0">
+                <a:solidFill>
+                  <a:srgbClr val="5B6B78"/>
+                </a:solidFill>
+                <a:latin typeface="Segoe UI"/>
+              </a:rPr>
+              <a:t>Indice 0–100 (4 dimensions/école, validé par ACP) — élevé = sous-équipé, à prioriser.</a:t>
             </a:r>
           </a:p>
         </p:txBody>

</xml_diff>